<commit_message>
feat: make workshop notebook interactions explicit
</commit_message>
<xml_diff>
--- a/slides/indabax-reliable-ai-agents-en.pptx
+++ b/slides/indabax-reliable-ai-agents-en.pptx
@@ -851,7 +851,7 @@
           <a:lstStyle/>
           <a:p>
             <a:r>
-              <a:t>0:09–0:10. Introduce the failures before their implementation. Each becomes observable in the notebook. From 10 to 14 minutes, open the notebook and run setup. Form pairs and predict the first call before checkpoint 1.</a:t>
+              <a:t>0:09–0:10. The notebook starts with the client contract and a chat without tools. Introduce the failures before their implementation. Each becomes observable in the notebook. From 10 to 14 minutes, open the notebook and run setup. Form pairs and predict the first call before checkpoint 1.</a:t>
             </a:r>
           </a:p>
         </p:txBody>
@@ -1062,7 +1062,7 @@
           <a:lstStyle/>
           <a:p>
             <a:r>
-              <a:t>0:14–0:22. Setup is complete. Model role: predict the tool and arguments. Orchestrator role: explain why this function can answer the question. Preview uses the simulator; the full mission uses Gemini when available. At minute 22, provide this checkpoint’s solution if needed.</a:t>
+              <a:t>0:14–0:22. Setup is complete. Model role: predict the tool and arguments. Orchestrator role: explain why this function can answer the question. Read the client contract, observe chat without tools, then request a tool using the selected client. The mode is displayed. At minute 22, provide this checkpoint’s solution if needed.</a:t>
             </a:r>
           </a:p>
         </p:txBody>
@@ -1273,7 +1273,7 @@
           <a:lstStyle/>
           <a:p>
             <a:r>
-              <a:t>0:22–0:31. TODO 3–4: execute with provenance checks and record the trace. TODO 5–6: keep the assistant proposal and tool result. Read one trace entry. Ask what the next turn would be missing without this observation.</a:t>
+              <a:t>0:22–0:31. Execution and tracing are provided: run them and inspect the result. TODO 2: keep the assistant proposal and tool result. Read one trace entry. Ask what the next turn would be missing without this observation.</a:t>
             </a:r>
           </a:p>
         </p:txBody>
@@ -1394,7 +1394,7 @@
           <a:lstStyle/>
           <a:p>
             <a:r>
-              <a:t>0:31–0:41. Swap roles. Use slide 14 for the missing-approval example, then return here. Complete the TODOs, run the Gemini mission, and rerun the failure case. Choose another fault: altered measurement, rejected approval or repetition. Rerun a corrected mission before evaluating it.</a:t>
+              <a:t>0:31–0:41. Swap roles. Use slide 14 for the missing-approval example, then return here. Observe the fault, complete the TODO 3 condition, replay the same fault, then run the mission. Choose another fault: altered measurement, rejected approval or repetition. Rerun a corrected mission before evaluating it.</a:t>
             </a:r>
           </a:p>
         </p:txBody>
@@ -1604,7 +1604,7 @@
           <a:lstStyle/>
           <a:p>
             <a:r>
-              <a:t>0:42–0:46. This checkpoint shares the five-minute 41–46 block with slides 15 and 17. TODO 10 must require all conditions with all(row['checks'].values()). Read and justify one PASS. All ten scenarios run without API calls. After a correction, rerun mission_run and then the evaluations if the dossier remains locked.</a:t>
+              <a:t>0:42–0:46. This checkpoint shares the five-minute 41–46 block with slides 15 and 17. TODO 4 must require all conditions with all(row['checks'].values()). Read and justify one PASS. All ten scenarios run without API calls. After a correction, rerun mission_run and then the evaluations if the dossier remains locked.</a:t>
             </a:r>
           </a:p>
         </p:txBody>
@@ -8092,7 +8092,7 @@
                 </a:solidFill>
                 <a:latin typeface="Poppins"/>
               </a:rPr>
-              <a:t>Turn the alert into a request for the first reading.</a:t>
+              <a:t>From chatbot to the first tool call.</a:t>
             </a:r>
           </a:p>
         </p:txBody>
@@ -8434,7 +8434,7 @@
                 </a:solidFill>
                 <a:latin typeface="Poppins"/>
               </a:rPr>
-              <a:t>Complete TODO 1–2.</a:t>
+              <a:t>Complete TODO 1.</a:t>
             </a:r>
           </a:p>
         </p:txBody>
@@ -8776,7 +8776,7 @@
                 </a:solidFill>
                 <a:latin typeface="Poppins"/>
               </a:rPr>
-              <a:t>Deterministic preview in mock mode. The notebook explains how to use Gemini for the mission.</a:t>
+              <a:t>Chat then tool call with Gemini or labelled mock. Four decisions to complete.</a:t>
             </a:r>
           </a:p>
         </p:txBody>
@@ -9271,7 +9271,7 @@
                 </a:solidFill>
                 <a:latin typeface="Poppins"/>
               </a:rPr>
-              <a:t>Execute and trace the call: TODO 3–4.</a:t>
+              <a:t>Run the provided execution helper.</a:t>
             </a:r>
           </a:p>
         </p:txBody>
@@ -9442,7 +9442,7 @@
                 </a:solidFill>
                 <a:latin typeface="Poppins"/>
               </a:rPr>
-              <a:t>Update the history: TODO 5–6.</a:t>
+              <a:t>Update the history: TODO 2.</a:t>
             </a:r>
           </a:p>
         </p:txBody>
@@ -9613,7 +9613,7 @@
                 </a:solidFill>
                 <a:latin typeface="Poppins"/>
               </a:rPr>
-              <a:t>Read the first trace entry.</a:t>
+              <a:t>Run the next model turn.</a:t>
             </a:r>
           </a:p>
         </p:txBody>
@@ -9655,7 +9655,7 @@
                 </a:solidFill>
                 <a:latin typeface="Poppins"/>
               </a:rPr>
-              <a:t>Find the retrieved temperature and the call that produced it.</a:t>
+              <a:t>Observe the procedure lookup after the reading.</a:t>
             </a:r>
           </a:p>
         </p:txBody>
@@ -10230,7 +10230,7 @@
                 </a:solidFill>
                 <a:latin typeface="Poppins"/>
               </a:rPr>
-              <a:t>Check the evidence: TODO 7–8.</a:t>
+              <a:t>Complete the condition: TODO 3.</a:t>
             </a:r>
           </a:p>
         </p:txBody>
@@ -10401,7 +10401,7 @@
                 </a:solidFill>
                 <a:latin typeface="Poppins"/>
               </a:rPr>
-              <a:t>Block repeated calls: TODO 9.</a:t>
+              <a:t>Observe the provided guard.</a:t>
             </a:r>
           </a:p>
         </p:txBody>
@@ -10572,7 +10572,7 @@
                 </a:solidFill>
                 <a:latin typeface="Poppins"/>
               </a:rPr>
-              <a:t>Run the mission, then a failure case.</a:t>
+              <a:t>Compare before and after the fix.</a:t>
             </a:r>
           </a:p>
         </p:txBody>
@@ -13444,7 +13444,7 @@
                 </a:solidFill>
                 <a:latin typeface="Poppins"/>
               </a:rPr>
-              <a:t>Complete TODO 10.</a:t>
+              <a:t>Complete TODO 4.</a:t>
             </a:r>
           </a:p>
         </p:txBody>

</xml_diff>